<commit_message>
Publish reviewed DeepTag stage report
</commit_message>
<xml_diff>
--- a/assets/projects/apriltag-unity-pose/apriltag-unity-stage1-progress.pptx
+++ b/assets/projects/apriltag-unity-pose/apriltag-unity-stage1-progress.pptx
@@ -2,7 +2,7 @@
 <file path=ppt/presentation.xml><?xml version="1.0" encoding="utf-8"?>
 <p:presentation xmlns:a="http://schemas.openxmlformats.org/drawingml/2006/main" xmlns:r="http://schemas.openxmlformats.org/officeDocument/2006/relationships" xmlns:p="http://schemas.openxmlformats.org/presentationml/2006/main">
   <p:sldMasterIdLst>
-    <p:sldMasterId id="2147483648" r:id="rId10"/>
+    <p:sldMasterId id="2147483648" r:id="rId9"/>
   </p:sldMasterIdLst>
   <p:sldIdLst>
     <p:sldId id="256" r:id="rId1"/>
@@ -13,7 +13,6 @@
     <p:sldId id="261" r:id="rId6"/>
     <p:sldId id="262" r:id="rId7"/>
     <p:sldId id="263" r:id="rId8"/>
-    <p:sldId id="264" r:id="rId9"/>
   </p:sldIdLst>
   <p:sldSz cx="12192000" cy="6858000" type="wide"/>
   <p:notesSz cx="6858000" cy="9144000"/>
@@ -156,8 +155,8 @@
                 </a:solidFill>
               </a:rPr>
               <a:t>• 阶段 1 进度报告
-• 目标：在 360 度八等份可见面的立体结构上贴附 Tag，输出 6DoF 位姿驱动 Unity 虚拟物体。
-• 状态：创维 1600 已完成基础驱动验证；底层取流、IMU 同步和端侧鲁棒性仍是下一步重点。</a:t>
+• 目标：在 360 度八等份可见面的立体结构上部署 Tag，输出实体结构 6DoF 位姿并驱动 Unity 虚拟物体。
+• 状态：创维 1600 已完成基础闭环验证；底层取流、IMU 同步和端侧鲁棒性仍是下一阶段重点。</a:t>
             </a:r>
             <a:endParaRPr lang="zh-CN" sz="2300"/>
           </a:p>
@@ -189,7 +188,7 @@
                   <a:srgbClr val="172033"/>
                 </a:solidFill>
               </a:rPr>
-              <a:t>DeepTag 多面体位姿驱动 Unity · 阶段 1 进度报告 · 1/9</a:t>
+              <a:t>DeepTag 多面体位姿驱动 Unity · 阶段 1 进度报告 · 1/8</a:t>
             </a:r>
             <a:endParaRPr lang="zh-CN" sz="1300"/>
           </a:p>
@@ -288,7 +287,7 @@
               </a:rPr>
               <a:t>• 立体结构旋转 360 度，按 45 度均分 8 个可观测方向。
 • 每个方向都至少可看到一个贴有 AprilTag / DeepTag 的面。
-• 通过多 Tag 融合得到 xyz 平移与旋转，驱动 Unity 中的虚拟物体。</a:t>
+• 通过多 Tag 刚体融合得到 xyz 平移与三轴旋转，驱动 Unity 中的虚拟物体。</a:t>
             </a:r>
             <a:endParaRPr lang="zh-CN" sz="2300"/>
           </a:p>
@@ -320,7 +319,7 @@
                   <a:srgbClr val="172033"/>
                 </a:solidFill>
               </a:rPr>
-              <a:t>DeepTag 多面体位姿驱动 Unity · 阶段 1 进度报告 · 2/9</a:t>
+              <a:t>DeepTag 多面体位姿驱动 Unity · 阶段 1 进度报告 · 2/8</a:t>
             </a:r>
             <a:endParaRPr lang="zh-CN" sz="1300"/>
           </a:p>
@@ -385,7 +384,7 @@
                   <a:srgbClr val="172033"/>
                 </a:solidFill>
               </a:rPr>
-              <a:t>技术路线</a:t>
+              <a:t>最新技术路线答复</a:t>
             </a:r>
             <a:endParaRPr lang="zh-CN" sz="3600"/>
           </a:p>
@@ -417,9 +416,10 @@
                   <a:srgbClr val="172033"/>
                 </a:solidFill>
               </a:rPr>
-              <a:t>• 创维 1600 灰度图像取流 -&gt; DeepTag 检测 -&gt; 角点亚像素回归 -&gt; ID 解码。
-• 多面体刚体约束融合可见 Tag，PnP + 非线性重投影精修输出 6DoF。
-• 路线已从传统 AprilTag 推进到 DeepTag，以提升低光、运动模糊和遮挡鲁棒性。</a:t>
+              <a:t>• SDK 的 AprilTag 检测采用深度学习方案，对标 DeepArUco / DeepArUco++。
+• 检测网络定位 Tag 候选区域 / 热力图；角点精修网络完成亚像素角点回归。
+• 随后执行 ID 解码与纠错，最后通过 PnP + 非线性重投影精修输出位姿。
+• 该路线面向反光、弱暗光、运动模糊、弯曲贴附和遮挡等传统方案易失效工况。</a:t>
             </a:r>
             <a:endParaRPr lang="zh-CN" sz="2300"/>
           </a:p>
@@ -451,7 +451,7 @@
                   <a:srgbClr val="172033"/>
                 </a:solidFill>
               </a:rPr>
-              <a:t>DeepTag 多面体位姿驱动 Unity · 阶段 1 进度报告 · 3/9</a:t>
+              <a:t>DeepTag 多面体位姿驱动 Unity · 阶段 1 进度报告 · 3/8</a:t>
             </a:r>
             <a:endParaRPr lang="zh-CN" sz="1300"/>
           </a:p>
@@ -548,9 +548,9 @@
                   <a:srgbClr val="172033"/>
                 </a:solidFill>
               </a:rPr>
-              <a:t>• 已在创维 1600 上完成初步验证，可以进行基本 Unity 驱动。
+              <a:t>• 已在创维 1600 上完成初步闭环验证，可以进行 Unity 虚拟物体基础跟随。
 • 当前通过分时复用方式获取约 30fps 灰度图像。
-• 在无法严格对应 IMU 数据的情况下，已经完成大致精度和稳定性测试。
+• 在无法严格对应 IMU 数据的约束下，已完成基础精度、稳定性和可驱动性验证。
 • 阶段 1 需求问题已在参考 README 中完成答复。</a:t>
             </a:r>
             <a:endParaRPr lang="zh-CN" sz="2300"/>
@@ -583,7 +583,7 @@
                   <a:srgbClr val="172033"/>
                 </a:solidFill>
               </a:rPr>
-              <a:t>DeepTag 多面体位姿驱动 Unity · 阶段 1 进度报告 · 4/9</a:t>
+              <a:t>DeepTag 多面体位姿驱动 Unity · 阶段 1 进度报告 · 4/8</a:t>
             </a:r>
             <a:endParaRPr lang="zh-CN" sz="1300"/>
           </a:p>
@@ -648,7 +648,7 @@
                   <a:srgbClr val="172033"/>
                 </a:solidFill>
               </a:rPr>
-              <a:t>当前限制</a:t>
+              <a:t>README 进度答复</a:t>
             </a:r>
             <a:endParaRPr lang="zh-CN" sz="3600"/>
           </a:p>
@@ -680,9 +680,9 @@
                   <a:srgbClr val="172033"/>
                 </a:solidFill>
               </a:rPr>
-              <a:t>• 尚未接入创维底层取流，分时复用导致偶发卡顿。
-• 灰度帧无法严格对应 IMU 数据，运动补偿和时序融合受限。
-• DeepTag 端侧实时性需要 NNAPI/NPU 或等价端侧加速继续验证。</a:t>
+              <a:t>• Q1：创维真机是硬依赖；算法主体可先离线推进，但标定、性能调优和 30 分钟稳定性必须在真机完成。
+• Q2：需明确取流 API、分辨率、帧率、像素格式、相机内参、畸变参数、外参/坐标系、时间戳和 IMU 可用性。
+• Q3：Tag 尺寸初步参考 22~28mm；材质需抗反光、可贴合曲面、耐磨耐汗；数量采用多 Tag 冗余分布。</a:t>
             </a:r>
             <a:endParaRPr lang="zh-CN" sz="2300"/>
           </a:p>
@@ -714,7 +714,7 @@
                   <a:srgbClr val="172033"/>
                 </a:solidFill>
               </a:rPr>
-              <a:t>DeepTag 多面体位姿驱动 Unity · 阶段 1 进度报告 · 5/9</a:t>
+              <a:t>DeepTag 多面体位姿驱动 Unity · 阶段 1 进度报告 · 5/8</a:t>
             </a:r>
             <a:endParaRPr lang="zh-CN" sz="1300"/>
           </a:p>
@@ -779,7 +779,7 @@
                   <a:srgbClr val="172033"/>
                 </a:solidFill>
               </a:rPr>
-              <a:t>流程图</a:t>
+              <a:t>当前限制</a:t>
             </a:r>
             <a:endParaRPr lang="zh-CN" sz="3600"/>
           </a:p>
@@ -811,8 +811,10 @@
                   <a:srgbClr val="172033"/>
                 </a:solidFill>
               </a:rPr>
-              <a:t>• 创维 1600 取流 -&gt; DeepTag 检测 -&gt; 多 Tag 融合 -&gt; PnP 位姿 -&gt; Unity 驱动。
-• 每个环节输出可观测 QC：检测置信度、角点残差、重投影误差、帧延迟和位姿抖动。</a:t>
+              <a:t>• 尚未接入创维底层取流，分时复用导致偶发帧间停顿。
+• 灰度帧无法严格对应 IMU 数据，运动补偿和时序融合受限。
+• DeepTag 端侧实时性需要 NNAPI/NPU 或等价端侧加速继续验证。
+• 后续需要用检测置信度、角点残差、重投影误差、帧延迟和位姿抖动做 QC。</a:t>
             </a:r>
             <a:endParaRPr lang="zh-CN" sz="2300"/>
           </a:p>
@@ -844,7 +846,7 @@
                   <a:srgbClr val="172033"/>
                 </a:solidFill>
               </a:rPr>
-              <a:t>DeepTag 多面体位姿驱动 Unity · 阶段 1 进度报告 · 6/9</a:t>
+              <a:t>DeepTag 多面体位姿驱动 Unity · 阶段 1 进度报告 · 6/8</a:t>
             </a:r>
             <a:endParaRPr lang="zh-CN" sz="1300"/>
           </a:p>
@@ -909,7 +911,7 @@
                   <a:srgbClr val="172033"/>
                 </a:solidFill>
               </a:rPr>
-              <a:t>拓扑与知识图谱</a:t>
+              <a:t>下一步计划</a:t>
             </a:r>
             <a:endParaRPr lang="zh-CN" sz="3600"/>
           </a:p>
@@ -941,9 +943,10 @@
                   <a:srgbClr val="172033"/>
                 </a:solidFill>
               </a:rPr>
-              <a:t>• 实体多面体：八方向可见面、Tag ID、每面外参。
-• 设备侧：创维 1600、相机内参、畸变参数、灰度取流、时间戳。
-• 算法侧：DeepTag、角点回归、PnP、非线性优化、Unity 坐标系转换。</a:t>
+              <a:t>• 接入创维底层取流、时间戳和 IMU 同步接口。
+• 对 STL/STP 结构建立每面 Tag 坐标系和刚体外参。
+• 补充低光、运动模糊、反光和遮挡样本，完成 DeepTag 端侧压缩。
+• 建立 Unity 日志，量化延迟、丢帧、重投影误差和 6DoF 抖动。</a:t>
             </a:r>
             <a:endParaRPr lang="zh-CN" sz="2300"/>
           </a:p>
@@ -975,7 +978,7 @@
                   <a:srgbClr val="172033"/>
                 </a:solidFill>
               </a:rPr>
-              <a:t>DeepTag 多面体位姿驱动 Unity · 阶段 1 进度报告 · 7/9</a:t>
+              <a:t>DeepTag 多面体位姿驱动 Unity · 阶段 1 进度报告 · 7/8</a:t>
             </a:r>
             <a:endParaRPr lang="zh-CN" sz="1300"/>
           </a:p>
@@ -1040,139 +1043,7 @@
                   <a:srgbClr val="172033"/>
                 </a:solidFill>
               </a:rPr>
-              <a:t>下一步计划</a:t>
-            </a:r>
-            <a:endParaRPr lang="zh-CN" sz="3600"/>
-          </a:p>
-        </p:txBody>
-      </p:sp>
-      <p:sp>
-        <p:nvSpPr>
-          <p:cNvPr id="3" name="Body"/>
-          <p:cNvSpPr txBox="1"/>
-          <p:nvPr/>
-        </p:nvSpPr>
-        <p:spPr>
-          <a:xfrm>
-            <a:off x="760000" y="1600000"/>
-            <a:ext cx="10600000" cy="4200000"/>
-          </a:xfrm>
-          <a:prstGeom prst="rect">
-            <a:avLst/>
-          </a:prstGeom>
-          <a:noFill/>
-        </p:spPr>
-        <p:txBody>
-          <a:bodyPr wrap="square"/>
-          <a:lstStyle/>
-          <a:p>
-            <a:r>
-              <a:rPr lang="zh-CN" sz="2300">
-                <a:solidFill>
-                  <a:srgbClr val="172033"/>
-                </a:solidFill>
-              </a:rPr>
-              <a:t>• 接入创维底层取流、时间戳和 IMU 同步接口。
-• 对 STL/STP 结构建立每面 Tag 坐标系和刚体外参。
-• 补充低光、运动模糊、反光和遮挡样本，完成 DeepTag 端侧压缩。
-• 建立 Unity 日志，量化延迟、丢帧、重投影误差和 6DoF 抖动。</a:t>
-            </a:r>
-            <a:endParaRPr lang="zh-CN" sz="2300"/>
-          </a:p>
-        </p:txBody>
-      </p:sp>
-      <p:sp>
-        <p:nvSpPr>
-          <p:cNvPr id="4" name="Footer"/>
-          <p:cNvSpPr txBox="1"/>
-          <p:nvPr/>
-        </p:nvSpPr>
-        <p:spPr>
-          <a:xfrm>
-            <a:off x="760000" y="6100000"/>
-            <a:ext cx="9800000" cy="360000"/>
-          </a:xfrm>
-          <a:prstGeom prst="rect">
-            <a:avLst/>
-          </a:prstGeom>
-          <a:noFill/>
-        </p:spPr>
-        <p:txBody>
-          <a:bodyPr wrap="square"/>
-          <a:lstStyle/>
-          <a:p>
-            <a:r>
-              <a:rPr lang="zh-CN" sz="1300">
-                <a:solidFill>
-                  <a:srgbClr val="172033"/>
-                </a:solidFill>
-              </a:rPr>
-              <a:t>DeepTag 多面体位姿驱动 Unity · 阶段 1 进度报告 · 8/9</a:t>
-            </a:r>
-            <a:endParaRPr lang="zh-CN" sz="1300"/>
-          </a:p>
-        </p:txBody>
-      </p:sp>
-    </p:spTree>
-  </p:cSld>
-  <p:clrMapOvr>
-    <a:masterClrMapping/>
-  </p:clrMapOvr>
-</p:sld>
-</file>
-
-<file path=ppt/slides/slide9.xml><?xml version="1.0" encoding="utf-8"?>
-<p:sld xmlns:a="http://schemas.openxmlformats.org/drawingml/2006/main" xmlns:r="http://schemas.openxmlformats.org/officeDocument/2006/relationships" xmlns:p="http://schemas.openxmlformats.org/presentationml/2006/main">
-  <p:cSld>
-    <p:bg>
-      <p:bgPr>
-        <a:solidFill>
-          <a:srgbClr val="EFE2C4"/>
-        </a:solidFill>
-        <a:effectLst/>
-      </p:bgPr>
-    </p:bg>
-    <p:spTree>
-      <p:nvGrpSpPr>
-        <p:cNvPr id="1" name=""/>
-        <p:cNvGrpSpPr/>
-        <p:nvPr/>
-      </p:nvGrpSpPr>
-      <p:grpSpPr>
-        <a:xfrm>
-          <a:off x="0" y="0"/>
-          <a:ext cx="0" cy="0"/>
-          <a:chOff x="0" y="0"/>
-          <a:chExt cx="0" cy="0"/>
-        </a:xfrm>
-      </p:grpSpPr>
-      <p:sp>
-        <p:nvSpPr>
-          <p:cNvPr id="2" name="Title"/>
-          <p:cNvSpPr txBox="1"/>
-          <p:nvPr/>
-        </p:nvSpPr>
-        <p:spPr>
-          <a:xfrm>
-            <a:off x="620000" y="520000"/>
-            <a:ext cx="10800000" cy="860000"/>
-          </a:xfrm>
-          <a:prstGeom prst="rect">
-            <a:avLst/>
-          </a:prstGeom>
-          <a:noFill/>
-        </p:spPr>
-        <p:txBody>
-          <a:bodyPr wrap="square"/>
-          <a:lstStyle/>
-          <a:p>
-            <a:r>
-              <a:rPr lang="zh-CN" sz="3600" b="1">
-                <a:solidFill>
-                  <a:srgbClr val="172033"/>
-                </a:solidFill>
-              </a:rPr>
-              <a:t>验收建议</a:t>
+              <a:t>验收口径</a:t>
             </a:r>
             <a:endParaRPr lang="zh-CN" sz="3600"/>
           </a:p>
@@ -1207,7 +1078,7 @@
               <a:t>• 单 Tag 正对稳定叠加，多 Tag 同时检测和融合。
 • 暗光、正常光、强光、运动模糊、25/50/75% 遮挡场景覆盖。
 • 0.3m 到 3m 距离范围，30 分钟稳定性测试。
-• 输出检测帧率、漏检率、位姿误差、重投影误差和 Unity 驱动延迟。</a:t>
+• 继续量化：角度误差、位置误差、检测帧率下限、漏检率上限和 Unity 驱动延迟。</a:t>
             </a:r>
             <a:endParaRPr lang="zh-CN" sz="2300"/>
           </a:p>
@@ -1239,7 +1110,7 @@
                   <a:srgbClr val="172033"/>
                 </a:solidFill>
               </a:rPr>
-              <a:t>DeepTag 多面体位姿驱动 Unity · 阶段 1 进度报告 · 9/9</a:t>
+              <a:t>DeepTag 多面体位姿驱动 Unity · 阶段 1 进度报告 · 8/8</a:t>
             </a:r>
             <a:endParaRPr lang="zh-CN" sz="1300"/>
           </a:p>

</xml_diff>

<commit_message>
Fix DeepTag report layout and model previews
</commit_message>
<xml_diff>
--- a/assets/projects/apriltag-unity-pose/apriltag-unity-stage1-progress.pptx
+++ b/assets/projects/apriltag-unity-pose/apriltag-unity-stage1-progress.pptx
@@ -813,8 +813,8 @@
               </a:rPr>
               <a:t>• 尚未接入创维底层取流，分时复用导致偶发帧间停顿。
 • 灰度帧无法严格对应 IMU 数据，运动补偿和时序融合受限。
-• DeepTag 端侧实时性需要 NNAPI/NPU 或等价端侧加速继续验证。
-• 后续需要用检测置信度、角点残差、重投影误差、帧延迟和位姿抖动做 QC。</a:t>
+• DeepTag 端侧实时性依赖 NNAPI/NPU 或等价端侧加速能力。
+• 当前 QC 关注检测置信度、角点残差、重投影误差、帧延迟和位姿抖动。</a:t>
             </a:r>
             <a:endParaRPr lang="zh-CN" sz="2300"/>
           </a:p>
@@ -911,7 +911,7 @@
                   <a:srgbClr val="172033"/>
                 </a:solidFill>
               </a:rPr>
-              <a:t>下一步计划</a:t>
+              <a:t>当前交付物</a:t>
             </a:r>
             <a:endParaRPr lang="zh-CN" sz="3600"/>
           </a:p>
@@ -943,10 +943,10 @@
                   <a:srgbClr val="172033"/>
                 </a:solidFill>
               </a:rPr>
-              <a:t>• 接入创维底层取流、时间戳和 IMU 同步接口。
-• 对 STL/STP 结构建立每面 Tag 坐标系和刚体外参。
-• 补充低光、运动模糊、反光和遮挡样本，完成 DeepTag 端侧压缩。
-• 建立 Unity 日志，量化延迟、丢帧、重投影误差和 6DoF 抖动。</a:t>
+              <a:t>• 创维 1600 初步闭环验证结论。
+• DeepTag 技术路线和端侧工程化约束说明。
+• STL/STP 结构模型文件与网页三维预览。
+• 网页进度报告和 PPT 进度报告。</a:t>
             </a:r>
             <a:endParaRPr lang="zh-CN" sz="2300"/>
           </a:p>

</xml_diff>

<commit_message>
Fix DeepTag report layout and STL previews
</commit_message>
<xml_diff>
--- a/assets/projects/apriltag-unity-pose/apriltag-unity-stage1-progress.pptx
+++ b/assets/projects/apriltag-unity-pose/apriltag-unity-stage1-progress.pptx
@@ -156,7 +156,7 @@
               </a:rPr>
               <a:t>• 阶段 1 进度报告
 • 目标：在 360 度八等份可见面的立体结构上部署 Tag，输出实体结构 6DoF 位姿并驱动 Unity 虚拟物体。
-• 状态：创维 1600 已完成基础闭环验证；底层取流、IMU 同步和端侧鲁棒性仍是下一阶段重点。</a:t>
+• 状态：创维 1600 已完成基础闭环验证；底层取流、IMU 同步和端侧鲁棒性约束已记录。</a:t>
             </a:r>
             <a:endParaRPr lang="zh-CN" sz="2300"/>
           </a:p>
@@ -811,7 +811,7 @@
                   <a:srgbClr val="172033"/>
                 </a:solidFill>
               </a:rPr>
-              <a:t>• 尚未接入创维底层取流，分时复用导致偶发帧间停顿。
+              <a:t>• 尚未接入创维底层取流，当前采用分时复用方式获取灰度帧。
 • 灰度帧无法严格对应 IMU 数据，运动补偿和时序融合受限。
 • DeepTag 端侧实时性依赖 NNAPI/NPU 或等价端侧加速能力。
 • 当前 QC 关注检测置信度、角点残差、重投影误差、帧延迟和位姿抖动。</a:t>
@@ -945,7 +945,7 @@
               </a:rPr>
               <a:t>• 创维 1600 初步闭环验证结论。
 • DeepTag 技术路线和端侧工程化约束说明。
-• STL/STP 结构模型文件与网页三维预览。
+• 第一代 4.stl 与第二代 2.stl 结构模型文件及网页三维预览。
 • 网页进度报告和 PPT 进度报告。</a:t>
             </a:r>
             <a:endParaRPr lang="zh-CN" sz="2300"/>
@@ -1078,7 +1078,7 @@
               <a:t>• 单 Tag 正对稳定叠加，多 Tag 同时检测和融合。
 • 暗光、正常光、强光、运动模糊、25/50/75% 遮挡场景覆盖。
 • 0.3m 到 3m 距离范围，30 分钟稳定性测试。
-• 继续量化：角度误差、位置误差、检测帧率下限、漏检率上限和 Unity 驱动延迟。</a:t>
+• 验收记录覆盖位姿叠加效果、可见距离、稳定运行时长和 Unity 驱动表现。</a:t>
             </a:r>
             <a:endParaRPr lang="zh-CN" sz="2300"/>
           </a:p>

</xml_diff>

<commit_message>
Add published project manifest and README Q&A detail
</commit_message>
<xml_diff>
--- a/assets/projects/apriltag-unity-pose/apriltag-unity-stage1-progress.pptx
+++ b/assets/projects/apriltag-unity-pose/apriltag-unity-stage1-progress.pptx
@@ -2,7 +2,7 @@
 <file path=ppt/presentation.xml><?xml version="1.0" encoding="utf-8"?>
 <p:presentation xmlns:a="http://schemas.openxmlformats.org/drawingml/2006/main" xmlns:r="http://schemas.openxmlformats.org/officeDocument/2006/relationships" xmlns:p="http://schemas.openxmlformats.org/presentationml/2006/main">
   <p:sldMasterIdLst>
-    <p:sldMasterId id="2147483648" r:id="rId9"/>
+    <p:sldMasterId id="2147483648" r:id="rId11"/>
   </p:sldMasterIdLst>
   <p:sldIdLst>
     <p:sldId id="256" r:id="rId1"/>
@@ -13,6 +13,8 @@
     <p:sldId id="261" r:id="rId6"/>
     <p:sldId id="262" r:id="rId7"/>
     <p:sldId id="263" r:id="rId8"/>
+    <p:sldId id="264" r:id="rId9"/>
+    <p:sldId id="265" r:id="rId10"/>
   </p:sldIdLst>
   <p:sldSz cx="12192000" cy="6858000" type="wide"/>
   <p:notesSz cx="6858000" cy="9144000"/>
@@ -156,7 +158,7 @@
               </a:rPr>
               <a:t>• 阶段 1 进度报告
 • 目标：在 360 度八等份可见面的立体结构上部署 Tag，输出实体结构 6DoF 位姿并驱动 Unity 虚拟物体。
-• 状态：创维 1600 已完成基础闭环验证；底层取流、IMU 同步和端侧鲁棒性约束已记录。</a:t>
+• 状态：创维 1600 已完成基础闭环验证；真机、SDK、Demo API 和端侧鲁棒性约束已记录。</a:t>
             </a:r>
             <a:endParaRPr lang="zh-CN" sz="2300"/>
           </a:p>
@@ -188,7 +190,139 @@
                   <a:srgbClr val="172033"/>
                 </a:solidFill>
               </a:rPr>
-              <a:t>DeepTag 多面体位姿驱动 Unity · 阶段 1 进度报告 · 1/8</a:t>
+              <a:t>DeepTag 多面体位姿驱动 Unity · 阶段 1 进度报告 · 1/10</a:t>
+            </a:r>
+            <a:endParaRPr lang="zh-CN" sz="1300"/>
+          </a:p>
+        </p:txBody>
+      </p:sp>
+    </p:spTree>
+  </p:cSld>
+  <p:clrMapOvr>
+    <a:masterClrMapping/>
+  </p:clrMapOvr>
+</p:sld>
+</file>
+
+<file path=ppt/slides/slide10.xml><?xml version="1.0" encoding="utf-8"?>
+<p:sld xmlns:a="http://schemas.openxmlformats.org/drawingml/2006/main" xmlns:r="http://schemas.openxmlformats.org/officeDocument/2006/relationships" xmlns:p="http://schemas.openxmlformats.org/presentationml/2006/main">
+  <p:cSld>
+    <p:bg>
+      <p:bgPr>
+        <a:solidFill>
+          <a:srgbClr val="EFE2C4"/>
+        </a:solidFill>
+        <a:effectLst/>
+      </p:bgPr>
+    </p:bg>
+    <p:spTree>
+      <p:nvGrpSpPr>
+        <p:cNvPr id="1" name=""/>
+        <p:cNvGrpSpPr/>
+        <p:nvPr/>
+      </p:nvGrpSpPr>
+      <p:grpSpPr>
+        <a:xfrm>
+          <a:off x="0" y="0"/>
+          <a:ext cx="0" cy="0"/>
+          <a:chOff x="0" y="0"/>
+          <a:chExt cx="0" cy="0"/>
+        </a:xfrm>
+      </p:grpSpPr>
+      <p:sp>
+        <p:nvSpPr>
+          <p:cNvPr id="2" name="Title"/>
+          <p:cNvSpPr txBox="1"/>
+          <p:nvPr/>
+        </p:nvSpPr>
+        <p:spPr>
+          <a:xfrm>
+            <a:off x="620000" y="520000"/>
+            <a:ext cx="10800000" cy="860000"/>
+          </a:xfrm>
+          <a:prstGeom prst="rect">
+            <a:avLst/>
+          </a:prstGeom>
+          <a:noFill/>
+        </p:spPr>
+        <p:txBody>
+          <a:bodyPr wrap="square"/>
+          <a:lstStyle/>
+          <a:p>
+            <a:r>
+              <a:rPr lang="zh-CN" sz="3600" b="1">
+                <a:solidFill>
+                  <a:srgbClr val="172033"/>
+                </a:solidFill>
+              </a:rPr>
+              <a:t>验收口径</a:t>
+            </a:r>
+            <a:endParaRPr lang="zh-CN" sz="3600"/>
+          </a:p>
+        </p:txBody>
+      </p:sp>
+      <p:sp>
+        <p:nvSpPr>
+          <p:cNvPr id="3" name="Body"/>
+          <p:cNvSpPr txBox="1"/>
+          <p:nvPr/>
+        </p:nvSpPr>
+        <p:spPr>
+          <a:xfrm>
+            <a:off x="760000" y="1600000"/>
+            <a:ext cx="10600000" cy="4200000"/>
+          </a:xfrm>
+          <a:prstGeom prst="rect">
+            <a:avLst/>
+          </a:prstGeom>
+          <a:noFill/>
+        </p:spPr>
+        <p:txBody>
+          <a:bodyPr wrap="square"/>
+          <a:lstStyle/>
+          <a:p>
+            <a:r>
+              <a:rPr lang="zh-CN" sz="2300">
+                <a:solidFill>
+                  <a:srgbClr val="172033"/>
+                </a:solidFill>
+              </a:rPr>
+              <a:t>• 单 Tag 正对稳定叠加，多 Tag 同时检测和融合。
+• 暗光、正常光、强光、运动模糊、25/50% 遮挡场景覆盖；75% 遮挡当前不建议作为标准验收项。
+• 0.3m 到 3m 距离范围，30 分钟稳定性测试。
+• 验收游戏/场景当前倾向击剑，需在需求文档中最终明确。</a:t>
+            </a:r>
+            <a:endParaRPr lang="zh-CN" sz="2300"/>
+          </a:p>
+        </p:txBody>
+      </p:sp>
+      <p:sp>
+        <p:nvSpPr>
+          <p:cNvPr id="4" name="Footer"/>
+          <p:cNvSpPr txBox="1"/>
+          <p:nvPr/>
+        </p:nvSpPr>
+        <p:spPr>
+          <a:xfrm>
+            <a:off x="760000" y="6100000"/>
+            <a:ext cx="9800000" cy="360000"/>
+          </a:xfrm>
+          <a:prstGeom prst="rect">
+            <a:avLst/>
+          </a:prstGeom>
+          <a:noFill/>
+        </p:spPr>
+        <p:txBody>
+          <a:bodyPr wrap="square"/>
+          <a:lstStyle/>
+          <a:p>
+            <a:r>
+              <a:rPr lang="zh-CN" sz="1300">
+                <a:solidFill>
+                  <a:srgbClr val="172033"/>
+                </a:solidFill>
+              </a:rPr>
+              <a:t>DeepTag 多面体位姿驱动 Unity · 阶段 1 进度报告 · 10/10</a:t>
             </a:r>
             <a:endParaRPr lang="zh-CN" sz="1300"/>
           </a:p>
@@ -319,7 +453,7 @@
                   <a:srgbClr val="172033"/>
                 </a:solidFill>
               </a:rPr>
-              <a:t>DeepTag 多面体位姿驱动 Unity · 阶段 1 进度报告 · 2/8</a:t>
+              <a:t>DeepTag 多面体位姿驱动 Unity · 阶段 1 进度报告 · 2/10</a:t>
             </a:r>
             <a:endParaRPr lang="zh-CN" sz="1300"/>
           </a:p>
@@ -416,10 +550,11 @@
                   <a:srgbClr val="172033"/>
                 </a:solidFill>
               </a:rPr>
-              <a:t>• SDK 的 AprilTag 检测采用深度学习方案，对标 DeepArUco / DeepArUco++。
+              <a:t>• 回答方：中数元宇。
+• SDK 的 AprilTag 检测采用自研 DeepApriltag 深度学习方案。
 • 检测网络定位 Tag 候选区域 / 热力图；角点精修网络完成亚像素角点回归。
 • 随后执行 ID 解码与纠错，最后通过 PnP + 非线性重投影精修输出位姿。
-• 该路线面向反光、弱暗光、运动模糊、弯曲贴附和遮挡等传统方案易失效工况。</a:t>
+• 该路线面向反光、弱暗光、运动模糊、极端角度、快速尺度变化和遮挡等传统方案易失效工况。</a:t>
             </a:r>
             <a:endParaRPr lang="zh-CN" sz="2300"/>
           </a:p>
@@ -451,7 +586,7 @@
                   <a:srgbClr val="172033"/>
                 </a:solidFill>
               </a:rPr>
-              <a:t>DeepTag 多面体位姿驱动 Unity · 阶段 1 进度报告 · 3/8</a:t>
+              <a:t>DeepTag 多面体位姿驱动 Unity · 阶段 1 进度报告 · 3/10</a:t>
             </a:r>
             <a:endParaRPr lang="zh-CN" sz="1300"/>
           </a:p>
@@ -583,7 +718,7 @@
                   <a:srgbClr val="172033"/>
                 </a:solidFill>
               </a:rPr>
-              <a:t>DeepTag 多面体位姿驱动 Unity · 阶段 1 进度报告 · 4/8</a:t>
+              <a:t>DeepTag 多面体位姿驱动 Unity · 阶段 1 进度报告 · 4/10</a:t>
             </a:r>
             <a:endParaRPr lang="zh-CN" sz="1300"/>
           </a:p>
@@ -680,9 +815,9 @@
                   <a:srgbClr val="172033"/>
                 </a:solidFill>
               </a:rPr>
-              <a:t>• Q1：创维真机是硬依赖；算法主体可先离线推进，但标定、性能调优和 30 分钟稳定性必须在真机完成。
-• Q2：需明确取流 API、分辨率、帧率、像素格式、相机内参、畸变参数、外参/坐标系、时间戳和 IMU 可用性。
-• Q3：Tag 尺寸初步参考 22~28mm；材质需抗反光、可贴合曲面、耐磨耐汗；数量采用多 Tag 冗余分布。</a:t>
+              <a:t>• Q1：创维眼镜真机是硬依赖；相机标定、性能调优、端侧推理帧率和 30 分钟稳定性测试必须在真机完成。
+• 中数元宇提供创维眼镜固件版本、SXR_SDK、修改后的高通 SDK、灰度摄像头调用和坐标转换方法。
+• 光速侧提供游戏 Demo、明确 Demo 形式，并暴露驱动击剑物体的 API。</a:t>
             </a:r>
             <a:endParaRPr lang="zh-CN" sz="2300"/>
           </a:p>
@@ -714,7 +849,7 @@
                   <a:srgbClr val="172033"/>
                 </a:solidFill>
               </a:rPr>
-              <a:t>DeepTag 多面体位姿驱动 Unity · 阶段 1 进度报告 · 5/8</a:t>
+              <a:t>DeepTag 多面体位姿驱动 Unity · 阶段 1 进度报告 · 5/10</a:t>
             </a:r>
             <a:endParaRPr lang="zh-CN" sz="1300"/>
           </a:p>
@@ -813,7 +948,7 @@
               </a:rPr>
               <a:t>• 尚未接入创维底层取流，当前采用分时复用方式获取灰度帧。
 • 灰度帧无法严格对应 IMU 数据，运动补偿和时序融合受限。
-• DeepTag 端侧实时性依赖 NNAPI/NPU 或等价端侧加速能力。
+• DeepApriltag 端侧实时性依赖 NNAPI / NPU-RK3588 或等价端侧加速能力。
 • 当前 QC 关注检测置信度、角点残差、重投影误差、帧延迟和位姿抖动。</a:t>
             </a:r>
             <a:endParaRPr lang="zh-CN" sz="2300"/>
@@ -846,7 +981,7 @@
                   <a:srgbClr val="172033"/>
                 </a:solidFill>
               </a:rPr>
-              <a:t>DeepTag 多面体位姿驱动 Unity · 阶段 1 进度报告 · 6/8</a:t>
+              <a:t>DeepTag 多面体位姿驱动 Unity · 阶段 1 进度报告 · 6/10</a:t>
             </a:r>
             <a:endParaRPr lang="zh-CN" sz="1300"/>
           </a:p>
@@ -911,7 +1046,7 @@
                   <a:srgbClr val="172033"/>
                 </a:solidFill>
               </a:rPr>
-              <a:t>当前交付物</a:t>
+              <a:t>Q2 图像数据与标定</a:t>
             </a:r>
             <a:endParaRPr lang="zh-CN" sz="3600"/>
           </a:p>
@@ -943,10 +1078,10 @@
                   <a:srgbClr val="172033"/>
                 </a:solidFill>
               </a:rPr>
-              <a:t>• 创维 1600 初步闭环验证结论。
-• DeepTag 技术路线和端侧工程化约束说明。
-• 第一代 4.stl 与第二代 2.stl 结构模型文件及网页三维预览。
-• 网页进度报告和 PPT 进度报告。</a:t>
+              <a:t>• 头显图像数据是算法精度与实时性的关键输入，由中数侧随 SDK 和文档提供。
+• 原始帧获取：取流 API / 回调、分辨率、帧率、像素格式、是否零拷贝。
+• 标定参数：相机内参、畸变模型及系数、相机相对头显/显示坐标系的外参。
+• 同步信息：帧时间戳、曝光/增益可读性、IMU 可用性。</a:t>
             </a:r>
             <a:endParaRPr lang="zh-CN" sz="2300"/>
           </a:p>
@@ -978,7 +1113,7 @@
                   <a:srgbClr val="172033"/>
                 </a:solidFill>
               </a:rPr>
-              <a:t>DeepTag 多面体位姿驱动 Unity · 阶段 1 进度报告 · 7/8</a:t>
+              <a:t>DeepTag 多面体位姿驱动 Unity · 阶段 1 进度报告 · 7/10</a:t>
             </a:r>
             <a:endParaRPr lang="zh-CN" sz="1300"/>
           </a:p>
@@ -1043,7 +1178,7 @@
                   <a:srgbClr val="172033"/>
                 </a:solidFill>
               </a:rPr>
-              <a:t>验收口径</a:t>
+              <a:t>Q3 Tag 选型</a:t>
             </a:r>
             <a:endParaRPr lang="zh-CN" sz="3600"/>
           </a:p>
@@ -1075,10 +1210,10 @@
                   <a:srgbClr val="172033"/>
                 </a:solidFill>
               </a:rPr>
-              <a:t>• 单 Tag 正对稳定叠加，多 Tag 同时检测和融合。
-• 暗光、正常光、强光、运动模糊、25/50/75% 遮挡场景覆盖。
-• 0.3m 到 3m 距离范围，30 分钟稳定性测试。
-• 验收记录覆盖位姿叠加效果、可见距离、稳定运行时长和 Unity 驱动表现。</a:t>
+              <a:t>• Tag 尺寸参考 20~40mm；近距小尺寸、远距大尺寸，可多尺寸混用。
+• 最终尺寸通过光照、运动、尺度变化、距离等条件交叉验证确定。
+• 材质参考标定板方案，需抗反光、漫反射、可贴合、耐磨耐汗。
+• 剑体和护具采用多枚冗余分布，多 Tag 按刚体分组并分配 ID 段。</a:t>
             </a:r>
             <a:endParaRPr lang="zh-CN" sz="2300"/>
           </a:p>
@@ -1110,7 +1245,139 @@
                   <a:srgbClr val="172033"/>
                 </a:solidFill>
               </a:rPr>
-              <a:t>DeepTag 多面体位姿驱动 Unity · 阶段 1 进度报告 · 8/8</a:t>
+              <a:t>DeepTag 多面体位姿驱动 Unity · 阶段 1 进度报告 · 8/10</a:t>
+            </a:r>
+            <a:endParaRPr lang="zh-CN" sz="1300"/>
+          </a:p>
+        </p:txBody>
+      </p:sp>
+    </p:spTree>
+  </p:cSld>
+  <p:clrMapOvr>
+    <a:masterClrMapping/>
+  </p:clrMapOvr>
+</p:sld>
+</file>
+
+<file path=ppt/slides/slide9.xml><?xml version="1.0" encoding="utf-8"?>
+<p:sld xmlns:a="http://schemas.openxmlformats.org/drawingml/2006/main" xmlns:r="http://schemas.openxmlformats.org/officeDocument/2006/relationships" xmlns:p="http://schemas.openxmlformats.org/presentationml/2006/main">
+  <p:cSld>
+    <p:bg>
+      <p:bgPr>
+        <a:solidFill>
+          <a:srgbClr val="EFE2C4"/>
+        </a:solidFill>
+        <a:effectLst/>
+      </p:bgPr>
+    </p:bg>
+    <p:spTree>
+      <p:nvGrpSpPr>
+        <p:cNvPr id="1" name=""/>
+        <p:cNvGrpSpPr/>
+        <p:nvPr/>
+      </p:nvGrpSpPr>
+      <p:grpSpPr>
+        <a:xfrm>
+          <a:off x="0" y="0"/>
+          <a:ext cx="0" cy="0"/>
+          <a:chOff x="0" y="0"/>
+          <a:chExt cx="0" cy="0"/>
+        </a:xfrm>
+      </p:grpSpPr>
+      <p:sp>
+        <p:nvSpPr>
+          <p:cNvPr id="2" name="Title"/>
+          <p:cNvSpPr txBox="1"/>
+          <p:nvPr/>
+        </p:nvSpPr>
+        <p:spPr>
+          <a:xfrm>
+            <a:off x="620000" y="520000"/>
+            <a:ext cx="10800000" cy="860000"/>
+          </a:xfrm>
+          <a:prstGeom prst="rect">
+            <a:avLst/>
+          </a:prstGeom>
+          <a:noFill/>
+        </p:spPr>
+        <p:txBody>
+          <a:bodyPr wrap="square"/>
+          <a:lstStyle/>
+          <a:p>
+            <a:r>
+              <a:rPr lang="zh-CN" sz="3600" b="1">
+                <a:solidFill>
+                  <a:srgbClr val="172033"/>
+                </a:solidFill>
+              </a:rPr>
+              <a:t>当前交付物</a:t>
+            </a:r>
+            <a:endParaRPr lang="zh-CN" sz="3600"/>
+          </a:p>
+        </p:txBody>
+      </p:sp>
+      <p:sp>
+        <p:nvSpPr>
+          <p:cNvPr id="3" name="Body"/>
+          <p:cNvSpPr txBox="1"/>
+          <p:nvPr/>
+        </p:nvSpPr>
+        <p:spPr>
+          <a:xfrm>
+            <a:off x="760000" y="1600000"/>
+            <a:ext cx="10600000" cy="4200000"/>
+          </a:xfrm>
+          <a:prstGeom prst="rect">
+            <a:avLst/>
+          </a:prstGeom>
+          <a:noFill/>
+        </p:spPr>
+        <p:txBody>
+          <a:bodyPr wrap="square"/>
+          <a:lstStyle/>
+          <a:p>
+            <a:r>
+              <a:rPr lang="zh-CN" sz="2300">
+                <a:solidFill>
+                  <a:srgbClr val="172033"/>
+                </a:solidFill>
+              </a:rPr>
+              <a:t>• 创维 1600 初步闭环验证结论。
+• DeepTag 技术路线和端侧工程化约束说明。
+• 第一代 4.stl 与第二代 2.stl 结构模型文件及网页三维预览。
+• 网页进度报告和 PPT 进度报告。</a:t>
+            </a:r>
+            <a:endParaRPr lang="zh-CN" sz="2300"/>
+          </a:p>
+        </p:txBody>
+      </p:sp>
+      <p:sp>
+        <p:nvSpPr>
+          <p:cNvPr id="4" name="Footer"/>
+          <p:cNvSpPr txBox="1"/>
+          <p:nvPr/>
+        </p:nvSpPr>
+        <p:spPr>
+          <a:xfrm>
+            <a:off x="760000" y="6100000"/>
+            <a:ext cx="9800000" cy="360000"/>
+          </a:xfrm>
+          <a:prstGeom prst="rect">
+            <a:avLst/>
+          </a:prstGeom>
+          <a:noFill/>
+        </p:spPr>
+        <p:txBody>
+          <a:bodyPr wrap="square"/>
+          <a:lstStyle/>
+          <a:p>
+            <a:r>
+              <a:rPr lang="zh-CN" sz="1300">
+                <a:solidFill>
+                  <a:srgbClr val="172033"/>
+                </a:solidFill>
+              </a:rPr>
+              <a:t>DeepTag 多面体位姿驱动 Unity · 阶段 1 进度报告 · 9/10</a:t>
             </a:r>
             <a:endParaRPr lang="zh-CN" sz="1300"/>
           </a:p>

</xml_diff>